<commit_message>
Clear default reporter identity fields
</commit_message>
<xml_diff>
--- a/assets/templates/academic-clean.pptx
+++ b/assets/templates/academic-clean.pptx
@@ -201,7 +201,7 @@
           <a:p>
             <a:fld id="{8871A4E7-4E1B-4393-82B5-9CBC4A7CD20B}" type="datetimeFigureOut">
               <a:rPr lang="zh-CN" altLang="en-US" smtClean="0"/>
-              <a:t>2026/6/15</a:t>
+              <a:t>2026/6/16</a:t>
             </a:fld>
             <a:endParaRPr lang="zh-CN" altLang="en-US"/>
           </a:p>
@@ -1476,7 +1476,7 @@
           <a:p>
             <a:fld id="{59451A94-3463-4F78-BD40-69197134D371}" type="datetimeFigureOut">
               <a:rPr lang="zh-CN" altLang="en-US" smtClean="0"/>
-              <a:t>2026/6/15</a:t>
+              <a:t>2026/6/16</a:t>
             </a:fld>
             <a:endParaRPr lang="zh-CN" altLang="en-US"/>
           </a:p>
@@ -1674,7 +1674,7 @@
           <a:p>
             <a:fld id="{59451A94-3463-4F78-BD40-69197134D371}" type="datetimeFigureOut">
               <a:rPr lang="zh-CN" altLang="en-US" smtClean="0"/>
-              <a:t>2026/6/15</a:t>
+              <a:t>2026/6/16</a:t>
             </a:fld>
             <a:endParaRPr lang="zh-CN" altLang="en-US"/>
           </a:p>
@@ -1882,7 +1882,7 @@
           <a:p>
             <a:fld id="{59451A94-3463-4F78-BD40-69197134D371}" type="datetimeFigureOut">
               <a:rPr lang="zh-CN" altLang="en-US" smtClean="0"/>
-              <a:t>2026/6/15</a:t>
+              <a:t>2026/6/16</a:t>
             </a:fld>
             <a:endParaRPr lang="zh-CN" altLang="en-US"/>
           </a:p>
@@ -2080,7 +2080,7 @@
           <a:p>
             <a:fld id="{59451A94-3463-4F78-BD40-69197134D371}" type="datetimeFigureOut">
               <a:rPr lang="zh-CN" altLang="en-US" smtClean="0"/>
-              <a:t>2026/6/15</a:t>
+              <a:t>2026/6/16</a:t>
             </a:fld>
             <a:endParaRPr lang="zh-CN" altLang="en-US"/>
           </a:p>
@@ -2355,7 +2355,7 @@
           <a:p>
             <a:fld id="{59451A94-3463-4F78-BD40-69197134D371}" type="datetimeFigureOut">
               <a:rPr lang="zh-CN" altLang="en-US" smtClean="0"/>
-              <a:t>2026/6/15</a:t>
+              <a:t>2026/6/16</a:t>
             </a:fld>
             <a:endParaRPr lang="zh-CN" altLang="en-US"/>
           </a:p>
@@ -2620,7 +2620,7 @@
           <a:p>
             <a:fld id="{59451A94-3463-4F78-BD40-69197134D371}" type="datetimeFigureOut">
               <a:rPr lang="zh-CN" altLang="en-US" smtClean="0"/>
-              <a:t>2026/6/15</a:t>
+              <a:t>2026/6/16</a:t>
             </a:fld>
             <a:endParaRPr lang="zh-CN" altLang="en-US"/>
           </a:p>
@@ -3032,7 +3032,7 @@
           <a:p>
             <a:fld id="{59451A94-3463-4F78-BD40-69197134D371}" type="datetimeFigureOut">
               <a:rPr lang="zh-CN" altLang="en-US" smtClean="0"/>
-              <a:t>2026/6/15</a:t>
+              <a:t>2026/6/16</a:t>
             </a:fld>
             <a:endParaRPr lang="zh-CN" altLang="en-US"/>
           </a:p>
@@ -3173,7 +3173,7 @@
           <a:p>
             <a:fld id="{59451A94-3463-4F78-BD40-69197134D371}" type="datetimeFigureOut">
               <a:rPr lang="zh-CN" altLang="en-US" smtClean="0"/>
-              <a:t>2026/6/15</a:t>
+              <a:t>2026/6/16</a:t>
             </a:fld>
             <a:endParaRPr lang="zh-CN" altLang="en-US"/>
           </a:p>
@@ -3286,7 +3286,7 @@
           <a:p>
             <a:fld id="{59451A94-3463-4F78-BD40-69197134D371}" type="datetimeFigureOut">
               <a:rPr lang="zh-CN" altLang="en-US" smtClean="0"/>
-              <a:t>2026/6/15</a:t>
+              <a:t>2026/6/16</a:t>
             </a:fld>
             <a:endParaRPr lang="zh-CN" altLang="en-US"/>
           </a:p>
@@ -3597,7 +3597,7 @@
           <a:p>
             <a:fld id="{59451A94-3463-4F78-BD40-69197134D371}" type="datetimeFigureOut">
               <a:rPr lang="zh-CN" altLang="en-US" smtClean="0"/>
-              <a:t>2026/6/15</a:t>
+              <a:t>2026/6/16</a:t>
             </a:fld>
             <a:endParaRPr lang="zh-CN" altLang="en-US"/>
           </a:p>
@@ -3885,7 +3885,7 @@
           <a:p>
             <a:fld id="{59451A94-3463-4F78-BD40-69197134D371}" type="datetimeFigureOut">
               <a:rPr lang="zh-CN" altLang="en-US" smtClean="0"/>
-              <a:t>2026/6/15</a:t>
+              <a:t>2026/6/16</a:t>
             </a:fld>
             <a:endParaRPr lang="zh-CN" altLang="en-US"/>
           </a:p>
@@ -4126,7 +4126,7 @@
           <a:p>
             <a:fld id="{59451A94-3463-4F78-BD40-69197134D371}" type="datetimeFigureOut">
               <a:rPr lang="zh-CN" altLang="en-US" smtClean="0"/>
-              <a:t>2026/6/15</a:t>
+              <a:t>2026/6/16</a:t>
             </a:fld>
             <a:endParaRPr lang="zh-CN" altLang="en-US"/>
           </a:p>
@@ -5087,15 +5087,22 @@
               <a:buChar char="•"/>
             </a:pPr>
             <a:r>
-              <a:rPr lang="zh-CN" altLang="en-US" dirty="0">
+              <a:rPr lang="zh-CN" altLang="en-US">
                 <a:solidFill>
                   <a:schemeClr val="bg1"/>
                 </a:solidFill>
                 <a:latin typeface="微软雅黑" panose="020B0503020204020204" pitchFamily="34" charset="-122"/>
                 <a:ea typeface="微软雅黑" panose="020B0503020204020204" pitchFamily="34" charset="-122"/>
               </a:rPr>
-              <a:t>院系：想搞设计</a:t>
+              <a:t>院系：</a:t>
             </a:r>
+            <a:endParaRPr lang="zh-CN" altLang="en-US" dirty="0">
+              <a:solidFill>
+                <a:schemeClr val="bg1"/>
+              </a:solidFill>
+              <a:latin typeface="微软雅黑" panose="020B0503020204020204" pitchFamily="34" charset="-122"/>
+              <a:ea typeface="微软雅黑" panose="020B0503020204020204" pitchFamily="34" charset="-122"/>
+            </a:endParaRPr>
           </a:p>
         </p:txBody>
       </p:sp>
@@ -5126,15 +5133,22 @@
               <a:buChar char="•"/>
             </a:pPr>
             <a:r>
-              <a:rPr lang="zh-CN" altLang="en-US" dirty="0">
+              <a:rPr lang="zh-CN" altLang="en-US">
                 <a:solidFill>
                   <a:schemeClr val="bg1"/>
                 </a:solidFill>
                 <a:latin typeface="微软雅黑" panose="020B0503020204020204" pitchFamily="34" charset="-122"/>
                 <a:ea typeface="微软雅黑" panose="020B0503020204020204" pitchFamily="34" charset="-122"/>
               </a:rPr>
-              <a:t>专业：想搞设计</a:t>
+              <a:t>专业：</a:t>
             </a:r>
+            <a:endParaRPr lang="zh-CN" altLang="en-US" dirty="0">
+              <a:solidFill>
+                <a:schemeClr val="bg1"/>
+              </a:solidFill>
+              <a:latin typeface="微软雅黑" panose="020B0503020204020204" pitchFamily="34" charset="-122"/>
+              <a:ea typeface="微软雅黑" panose="020B0503020204020204" pitchFamily="34" charset="-122"/>
+            </a:endParaRPr>
           </a:p>
         </p:txBody>
       </p:sp>
@@ -5165,15 +5179,22 @@
               <a:buChar char="•"/>
             </a:pPr>
             <a:r>
-              <a:rPr lang="zh-CN" altLang="en-US" dirty="0">
+              <a:rPr lang="zh-CN" altLang="en-US">
                 <a:solidFill>
                   <a:schemeClr val="bg1"/>
                 </a:solidFill>
                 <a:latin typeface="微软雅黑" panose="020B0503020204020204" pitchFamily="34" charset="-122"/>
                 <a:ea typeface="微软雅黑" panose="020B0503020204020204" pitchFamily="34" charset="-122"/>
               </a:rPr>
-              <a:t>答辩人：想搞设计</a:t>
+              <a:t>答辩人：</a:t>
             </a:r>
+            <a:endParaRPr lang="zh-CN" altLang="en-US" dirty="0">
+              <a:solidFill>
+                <a:schemeClr val="bg1"/>
+              </a:solidFill>
+              <a:latin typeface="微软雅黑" panose="020B0503020204020204" pitchFamily="34" charset="-122"/>
+              <a:ea typeface="微软雅黑" panose="020B0503020204020204" pitchFamily="34" charset="-122"/>
+            </a:endParaRPr>
           </a:p>
         </p:txBody>
       </p:sp>
@@ -5204,15 +5225,22 @@
               <a:buChar char="•"/>
             </a:pPr>
             <a:r>
-              <a:rPr lang="zh-CN" altLang="en-US" dirty="0">
+              <a:rPr lang="zh-CN" altLang="en-US">
                 <a:solidFill>
                   <a:schemeClr val="bg1"/>
                 </a:solidFill>
                 <a:latin typeface="微软雅黑" panose="020B0503020204020204" pitchFamily="34" charset="-122"/>
                 <a:ea typeface="微软雅黑" panose="020B0503020204020204" pitchFamily="34" charset="-122"/>
               </a:rPr>
-              <a:t>指导老师：想搞设计</a:t>
+              <a:t>指导老师：</a:t>
             </a:r>
+            <a:endParaRPr lang="zh-CN" altLang="en-US" dirty="0">
+              <a:solidFill>
+                <a:schemeClr val="bg1"/>
+              </a:solidFill>
+              <a:latin typeface="微软雅黑" panose="020B0503020204020204" pitchFamily="34" charset="-122"/>
+              <a:ea typeface="微软雅黑" panose="020B0503020204020204" pitchFamily="34" charset="-122"/>
+            </a:endParaRPr>
           </a:p>
         </p:txBody>
       </p:sp>
@@ -6169,15 +6197,22 @@
                 <a:buChar char="•"/>
               </a:pPr>
               <a:r>
-                <a:rPr lang="zh-CN" altLang="en-US" sz="1400" dirty="0">
+                <a:rPr lang="zh-CN" altLang="en-US" sz="1400">
                   <a:solidFill>
                     <a:srgbClr val="95161C"/>
                   </a:solidFill>
                   <a:latin typeface="微软雅黑" panose="020B0503020204020204" pitchFamily="34" charset="-122"/>
                   <a:ea typeface="微软雅黑" panose="020B0503020204020204" pitchFamily="34" charset="-122"/>
                 </a:rPr>
-                <a:t>院系：设计学院 </a:t>
+                <a:t>院系： </a:t>
               </a:r>
+              <a:endParaRPr lang="zh-CN" altLang="en-US" sz="1400" dirty="0">
+                <a:solidFill>
+                  <a:srgbClr val="95161C"/>
+                </a:solidFill>
+                <a:latin typeface="微软雅黑" panose="020B0503020204020204" pitchFamily="34" charset="-122"/>
+                <a:ea typeface="微软雅黑" panose="020B0503020204020204" pitchFamily="34" charset="-122"/>
+              </a:endParaRPr>
             </a:p>
           </p:txBody>
         </p:sp>
@@ -6208,15 +6243,22 @@
                 <a:buChar char="•"/>
               </a:pPr>
               <a:r>
-                <a:rPr lang="zh-CN" altLang="en-US" sz="1400" dirty="0">
+                <a:rPr lang="zh-CN" altLang="en-US" sz="1400">
                   <a:solidFill>
                     <a:srgbClr val="95161C"/>
                   </a:solidFill>
                   <a:latin typeface="微软雅黑" panose="020B0503020204020204" pitchFamily="34" charset="-122"/>
                   <a:ea typeface="微软雅黑" panose="020B0503020204020204" pitchFamily="34" charset="-122"/>
                 </a:rPr>
-                <a:t>专业：设计学</a:t>
+                <a:t>专业：</a:t>
               </a:r>
+              <a:endParaRPr lang="zh-CN" altLang="en-US" sz="1400" dirty="0">
+                <a:solidFill>
+                  <a:srgbClr val="95161C"/>
+                </a:solidFill>
+                <a:latin typeface="微软雅黑" panose="020B0503020204020204" pitchFamily="34" charset="-122"/>
+                <a:ea typeface="微软雅黑" panose="020B0503020204020204" pitchFamily="34" charset="-122"/>
+              </a:endParaRPr>
             </a:p>
           </p:txBody>
         </p:sp>
@@ -6247,14 +6289,14 @@
                 <a:buChar char="•"/>
               </a:pPr>
               <a:r>
-                <a:rPr lang="zh-CN" altLang="en-US" sz="1400" dirty="0">
+                <a:rPr lang="zh-CN" altLang="en-US" sz="1400">
                   <a:solidFill>
                     <a:srgbClr val="95161C"/>
                   </a:solidFill>
                   <a:latin typeface="微软雅黑" panose="020B0503020204020204" pitchFamily="34" charset="-122"/>
                   <a:ea typeface="微软雅黑" panose="020B0503020204020204" pitchFamily="34" charset="-122"/>
                 </a:rPr>
-                <a:t>答辩人：XXX</a:t>
+                <a:t>答辩人：</a:t>
               </a:r>
               <a:endParaRPr lang="zh-CN" altLang="en-US" sz="1400" dirty="0">
                 <a:solidFill>
@@ -6293,14 +6335,14 @@
                 <a:buChar char="•"/>
               </a:pPr>
               <a:r>
-                <a:rPr lang="zh-CN" altLang="en-US" sz="1400" dirty="0">
+                <a:rPr lang="zh-CN" altLang="en-US" sz="1400">
                   <a:solidFill>
                     <a:srgbClr val="95161C"/>
                   </a:solidFill>
                   <a:latin typeface="微软雅黑" panose="020B0503020204020204" pitchFamily="34" charset="-122"/>
                   <a:ea typeface="微软雅黑" panose="020B0503020204020204" pitchFamily="34" charset="-122"/>
                 </a:rPr>
-                <a:t>指导老师：XXX</a:t>
+                <a:t>指导老师：</a:t>
               </a:r>
               <a:endParaRPr lang="zh-CN" altLang="en-US" sz="1400" dirty="0">
                 <a:solidFill>

</xml_diff>